<commit_message>
Orthotimer, draagdoel en eindpunt overal rechtgezet
- Orthotimer: 100 dagen is het geheugen (ringbuffer), niet de batterij
  (Lutjeboer 2018: batterij minstens 18 maanden); elke 3 maanden uitlezen,
  vervangen waar nodig (eCRF 30 en 33). Site, MOOC, decks, REDCap, CLAUDE.md.
- Waaktijd in plaats van actieve tijd/activiteitenvenster; de 80% heet de norm
  (eCRF 17, 25b, 28, 32 en REDCap-labels, alle kopieen).
- Eén primair eindpunt (recidief), therapietrouw is de mediator: site, MOOC,
  studieprotocolpagina en meetinstrumenten.
- Decks: nulstellen één keer per sessie, geboortedatum Orthotimer 1/1/1999.
- eCRF 09: geen multi-masktool meer vermeld; F-Scan acht regio's.

Co-Authored-By: Claude Opus 5.5 <noreply@anthropic.com>
</commit_message>
<xml_diff>
--- a/PARADISE_presentatie/PARADISE_extern.pptx
+++ b/PARADISE_presentatie/PARADISE_extern.pptx
@@ -9076,7 +9076,7 @@
                 </a:solidFill>
                 <a:latin typeface="Consolas"/>
               </a:rPr>
-              <a:t>80% van het eigen activiteitenprofiel</a:t>
+              <a:t>80% van de eigen waaktijd</a:t>
             </a:r>
           </a:p>
         </p:txBody>
@@ -59153,7 +59153,7 @@
                 </a:solidFill>
                 <a:latin typeface="Segoe UI"/>
               </a:rPr>
-              <a:t>Zeroing voor elke meting</a:t>
+              <a:t>Nulstellen: één keer per sessie</a:t>
             </a:r>
           </a:p>
           <a:p>
@@ -59465,7 +59465,7 @@
                 </a:solidFill>
                 <a:latin typeface="Segoe UI"/>
               </a:rPr>
-              <a:t>Batterij 100 dagen</a:t>
+              <a:t>Geheugen 100 dagen</a:t>
             </a:r>
           </a:p>
         </p:txBody>

</xml_diff>